<commit_message>
Add gallery thumbnails for HERD tutorials
Add dedicated thumbnails for the two HERD tutorials (authored in
gallery_thumbnails.pptx) and wire them in via sphinx_gallery_thumbnail_path.
Rename the single-file tutorial heading to "Linking to External Resources
(HERD)" to match its thumbnail.

Co-Authored-By: Claude Opus 4.8 (1M context) <noreply@anthropic.com>
</commit_message>
<xml_diff>
--- a/docs/source/figures/gallery_thumbnails.pptx
+++ b/docs/source/figures/gallery_thumbnails.pptx
@@ -5,7 +5,7 @@
     <p:sldMasterId id="2147483660" r:id="rId1"/>
   </p:sldMasterIdLst>
   <p:notesMasterIdLst>
-    <p:notesMasterId r:id="rId22"/>
+    <p:notesMasterId r:id="rId24"/>
   </p:notesMasterIdLst>
   <p:sldIdLst>
     <p:sldId id="342" r:id="rId2"/>
@@ -28,6 +28,8 @@
     <p:sldId id="359" r:id="rId19"/>
     <p:sldId id="366" r:id="rId20"/>
     <p:sldId id="367" r:id="rId21"/>
+    <p:sldId id="368" r:id="rId22"/>
+    <p:sldId id="369" r:id="rId23"/>
   </p:sldIdLst>
   <p:sldSz cx="12192000" cy="6858000"/>
   <p:notesSz cx="6858000" cy="9144000"/>
@@ -227,7 +229,7 @@
           <a:p>
             <a:fld id="{4D6A40B9-902A-4E0E-AF39-1C357549AEE0}" type="datetimeFigureOut">
               <a:rPr lang="en-US" smtClean="0"/>
-              <a:t>11/7/24</a:t>
+              <a:t>6/22/26</a:t>
             </a:fld>
             <a:endParaRPr lang="en-US"/>
           </a:p>
@@ -9445,6 +9447,1152 @@
 </p:sld>
 </file>
 
+<file path=ppt/slides/slide21.xml><?xml version="1.0" encoding="utf-8"?>
+<p:sld xmlns:a="http://schemas.openxmlformats.org/drawingml/2006/main" xmlns:r="http://schemas.openxmlformats.org/officeDocument/2006/relationships" xmlns:p="http://schemas.openxmlformats.org/presentationml/2006/main">
+  <p:cSld>
+    <p:spTree>
+      <p:nvGrpSpPr>
+        <p:cNvPr id="1" name="">
+          <a:extLst>
+            <a:ext uri="{FF2B5EF4-FFF2-40B4-BE49-F238E27FC236}">
+              <a16:creationId xmlns:a16="http://schemas.microsoft.com/office/drawing/2014/main" id="{71E4B4A6-73B7-86C7-8670-46D8D41DD2E0}"/>
+            </a:ext>
+          </a:extLst>
+        </p:cNvPr>
+        <p:cNvGrpSpPr/>
+        <p:nvPr/>
+      </p:nvGrpSpPr>
+      <p:grpSpPr>
+        <a:xfrm>
+          <a:off x="0" y="0"/>
+          <a:ext cx="0" cy="0"/>
+          <a:chOff x="0" y="0"/>
+          <a:chExt cx="0" cy="0"/>
+        </a:xfrm>
+      </p:grpSpPr>
+      <p:sp>
+        <p:nvSpPr>
+          <p:cNvPr id="27" name="Rounded Rectangle 26">
+            <a:extLst>
+              <a:ext uri="{FF2B5EF4-FFF2-40B4-BE49-F238E27FC236}">
+                <a16:creationId xmlns:a16="http://schemas.microsoft.com/office/drawing/2014/main" id="{5BC30344-1E85-01AE-B374-65D2A28A5CE4}"/>
+              </a:ext>
+            </a:extLst>
+          </p:cNvPr>
+          <p:cNvSpPr/>
+          <p:nvPr/>
+        </p:nvSpPr>
+        <p:spPr>
+          <a:xfrm>
+            <a:off x="853570" y="853671"/>
+            <a:ext cx="7234527" cy="4851352"/>
+          </a:xfrm>
+          <a:prstGeom prst="roundRect">
+            <a:avLst>
+              <a:gd name="adj" fmla="val 4437"/>
+            </a:avLst>
+          </a:prstGeom>
+          <a:solidFill>
+            <a:srgbClr val="EDEDED"/>
+          </a:solidFill>
+          <a:ln>
+            <a:solidFill>
+              <a:srgbClr val="000000"/>
+            </a:solidFill>
+          </a:ln>
+          <a:effectLst/>
+        </p:spPr>
+        <p:style>
+          <a:lnRef idx="1">
+            <a:schemeClr val="accent1"/>
+          </a:lnRef>
+          <a:fillRef idx="3">
+            <a:schemeClr val="accent1"/>
+          </a:fillRef>
+          <a:effectRef idx="2">
+            <a:schemeClr val="accent1"/>
+          </a:effectRef>
+          <a:fontRef idx="minor">
+            <a:schemeClr val="lt1"/>
+          </a:fontRef>
+        </p:style>
+        <p:txBody>
+          <a:bodyPr rtlCol="0" anchor="ctr"/>
+          <a:lstStyle/>
+          <a:p>
+            <a:pPr algn="ctr"/>
+            <a:endParaRPr lang="en-US"/>
+          </a:p>
+        </p:txBody>
+      </p:sp>
+      <p:sp>
+        <p:nvSpPr>
+          <p:cNvPr id="26" name="Rectangle 25">
+            <a:extLst>
+              <a:ext uri="{FF2B5EF4-FFF2-40B4-BE49-F238E27FC236}">
+                <a16:creationId xmlns:a16="http://schemas.microsoft.com/office/drawing/2014/main" id="{217F646C-9719-14B7-7C33-4C1EDEE3A37C}"/>
+              </a:ext>
+            </a:extLst>
+          </p:cNvPr>
+          <p:cNvSpPr/>
+          <p:nvPr/>
+        </p:nvSpPr>
+        <p:spPr>
+          <a:xfrm>
+            <a:off x="863980" y="855015"/>
+            <a:ext cx="7213708" cy="1754326"/>
+          </a:xfrm>
+          <a:prstGeom prst="rect">
+            <a:avLst/>
+          </a:prstGeom>
+        </p:spPr>
+        <p:txBody>
+          <a:bodyPr wrap="square">
+            <a:spAutoFit/>
+          </a:bodyPr>
+          <a:lstStyle/>
+          <a:p>
+            <a:pPr algn="ctr"/>
+            <a:r>
+              <a:rPr lang="en-US" sz="5400" b="1" dirty="0">
+                <a:solidFill>
+                  <a:srgbClr val="052B48"/>
+                </a:solidFill>
+                <a:latin typeface="Calibri"/>
+                <a:cs typeface="Calibri"/>
+              </a:rPr>
+              <a:t>Linking to External Resources (HERD)</a:t>
+            </a:r>
+          </a:p>
+        </p:txBody>
+      </p:sp>
+      <p:pic>
+        <p:nvPicPr>
+          <p:cNvPr id="2" name="Picture 1" descr="www-1632431_1280.png">
+            <a:extLst>
+              <a:ext uri="{FF2B5EF4-FFF2-40B4-BE49-F238E27FC236}">
+                <a16:creationId xmlns:a16="http://schemas.microsoft.com/office/drawing/2014/main" id="{93EF452C-A2C7-2115-F3BE-BF48BD25EA11}"/>
+              </a:ext>
+            </a:extLst>
+          </p:cNvPr>
+          <p:cNvPicPr>
+            <a:picLocks noChangeAspect="1"/>
+          </p:cNvPicPr>
+          <p:nvPr/>
+        </p:nvPicPr>
+        <p:blipFill>
+          <a:blip r:embed="rId2">
+            <a:duotone>
+              <a:schemeClr val="accent5">
+                <a:shade val="45000"/>
+                <a:satMod val="135000"/>
+              </a:schemeClr>
+              <a:prstClr val="white"/>
+            </a:duotone>
+            <a:extLst>
+              <a:ext uri="{28A0092B-C50C-407E-A947-70E740481C1C}">
+                <a14:useLocalDpi xmlns:a14="http://schemas.microsoft.com/office/drawing/2010/main" val="0"/>
+              </a:ext>
+            </a:extLst>
+          </a:blip>
+          <a:stretch>
+            <a:fillRect/>
+          </a:stretch>
+        </p:blipFill>
+        <p:spPr>
+          <a:xfrm>
+            <a:off x="3060191" y="2771177"/>
+            <a:ext cx="2824101" cy="2744673"/>
+          </a:xfrm>
+          <a:prstGeom prst="rect">
+            <a:avLst/>
+          </a:prstGeom>
+        </p:spPr>
+      </p:pic>
+    </p:spTree>
+    <p:extLst>
+      <p:ext uri="{BB962C8B-B14F-4D97-AF65-F5344CB8AC3E}">
+        <p14:creationId xmlns:p14="http://schemas.microsoft.com/office/powerpoint/2010/main" val="3871014493"/>
+      </p:ext>
+    </p:extLst>
+  </p:cSld>
+  <p:clrMapOvr>
+    <a:masterClrMapping/>
+  </p:clrMapOvr>
+</p:sld>
+</file>
+
+<file path=ppt/slides/slide22.xml><?xml version="1.0" encoding="utf-8"?>
+<p:sld xmlns:a="http://schemas.openxmlformats.org/drawingml/2006/main" xmlns:r="http://schemas.openxmlformats.org/officeDocument/2006/relationships" xmlns:p="http://schemas.openxmlformats.org/presentationml/2006/main">
+  <p:cSld>
+    <p:spTree>
+      <p:nvGrpSpPr>
+        <p:cNvPr id="1" name="">
+          <a:extLst>
+            <a:ext uri="{FF2B5EF4-FFF2-40B4-BE49-F238E27FC236}">
+              <a16:creationId xmlns:a16="http://schemas.microsoft.com/office/drawing/2014/main" id="{71E4B4A6-73B7-86C7-8670-46D8D41DD2E0}"/>
+            </a:ext>
+          </a:extLst>
+        </p:cNvPr>
+        <p:cNvGrpSpPr/>
+        <p:nvPr/>
+      </p:nvGrpSpPr>
+      <p:grpSpPr>
+        <a:xfrm>
+          <a:off x="0" y="0"/>
+          <a:ext cx="0" cy="0"/>
+          <a:chOff x="0" y="0"/>
+          <a:chExt cx="0" cy="0"/>
+        </a:xfrm>
+      </p:grpSpPr>
+      <p:sp>
+        <p:nvSpPr>
+          <p:cNvPr id="27" name="Rounded Rectangle 26">
+            <a:extLst>
+              <a:ext uri="{FF2B5EF4-FFF2-40B4-BE49-F238E27FC236}">
+                <a16:creationId xmlns:a16="http://schemas.microsoft.com/office/drawing/2014/main" id="{5BC30344-1E85-01AE-B374-65D2A28A5CE4}"/>
+              </a:ext>
+            </a:extLst>
+          </p:cNvPr>
+          <p:cNvSpPr/>
+          <p:nvPr/>
+        </p:nvSpPr>
+        <p:spPr>
+          <a:xfrm>
+            <a:off x="853570" y="853671"/>
+            <a:ext cx="7234527" cy="4851352"/>
+          </a:xfrm>
+          <a:prstGeom prst="roundRect">
+            <a:avLst>
+              <a:gd name="adj" fmla="val 4437"/>
+            </a:avLst>
+          </a:prstGeom>
+          <a:solidFill>
+            <a:srgbClr val="EDEDED"/>
+          </a:solidFill>
+          <a:ln>
+            <a:solidFill>
+              <a:srgbClr val="000000"/>
+            </a:solidFill>
+          </a:ln>
+          <a:effectLst/>
+        </p:spPr>
+        <p:style>
+          <a:lnRef idx="1">
+            <a:schemeClr val="accent1"/>
+          </a:lnRef>
+          <a:fillRef idx="3">
+            <a:schemeClr val="accent1"/>
+          </a:fillRef>
+          <a:effectRef idx="2">
+            <a:schemeClr val="accent1"/>
+          </a:effectRef>
+          <a:fontRef idx="minor">
+            <a:schemeClr val="lt1"/>
+          </a:fontRef>
+        </p:style>
+        <p:txBody>
+          <a:bodyPr rtlCol="0" anchor="ctr"/>
+          <a:lstStyle/>
+          <a:p>
+            <a:pPr algn="ctr"/>
+            <a:endParaRPr lang="en-US"/>
+          </a:p>
+        </p:txBody>
+      </p:sp>
+      <p:grpSp>
+        <p:nvGrpSpPr>
+          <p:cNvPr id="29" name="Group 28">
+            <a:extLst>
+              <a:ext uri="{FF2B5EF4-FFF2-40B4-BE49-F238E27FC236}">
+                <a16:creationId xmlns:a16="http://schemas.microsoft.com/office/drawing/2014/main" id="{0085A170-0FEE-0D68-8BFA-6C4F3670242F}"/>
+              </a:ext>
+            </a:extLst>
+          </p:cNvPr>
+          <p:cNvGrpSpPr/>
+          <p:nvPr/>
+        </p:nvGrpSpPr>
+        <p:grpSpPr>
+          <a:xfrm>
+            <a:off x="2176869" y="2683696"/>
+            <a:ext cx="1958014" cy="2088790"/>
+            <a:chOff x="2176869" y="2683696"/>
+            <a:chExt cx="1958014" cy="2088790"/>
+          </a:xfrm>
+        </p:grpSpPr>
+        <p:grpSp>
+          <p:nvGrpSpPr>
+            <p:cNvPr id="9" name="Group 8">
+              <a:extLst>
+                <a:ext uri="{FF2B5EF4-FFF2-40B4-BE49-F238E27FC236}">
+                  <a16:creationId xmlns:a16="http://schemas.microsoft.com/office/drawing/2014/main" id="{EFABE697-4470-7303-2915-C0BEFA0D1D1A}"/>
+                </a:ext>
+              </a:extLst>
+            </p:cNvPr>
+            <p:cNvGrpSpPr>
+              <a:grpSpLocks noChangeAspect="1"/>
+            </p:cNvGrpSpPr>
+            <p:nvPr/>
+          </p:nvGrpSpPr>
+          <p:grpSpPr>
+            <a:xfrm>
+              <a:off x="2176869" y="2683696"/>
+              <a:ext cx="1834490" cy="1875247"/>
+              <a:chOff x="1544285" y="1840138"/>
+              <a:chExt cx="3619836" cy="3700266"/>
+            </a:xfrm>
+          </p:grpSpPr>
+          <p:sp>
+            <p:nvSpPr>
+              <p:cNvPr id="10" name="Folded Corner 9">
+                <a:extLst>
+                  <a:ext uri="{FF2B5EF4-FFF2-40B4-BE49-F238E27FC236}">
+                    <a16:creationId xmlns:a16="http://schemas.microsoft.com/office/drawing/2014/main" id="{19EBA2B3-8673-CBCC-100B-268475967AC4}"/>
+                  </a:ext>
+                </a:extLst>
+              </p:cNvPr>
+              <p:cNvSpPr/>
+              <p:nvPr/>
+            </p:nvSpPr>
+            <p:spPr>
+              <a:xfrm rot="10800000" flipH="1">
+                <a:off x="2674222" y="2150156"/>
+                <a:ext cx="2489899" cy="3390248"/>
+              </a:xfrm>
+              <a:prstGeom prst="foldedCorner">
+                <a:avLst>
+                  <a:gd name="adj" fmla="val 26556"/>
+                </a:avLst>
+              </a:prstGeom>
+              <a:solidFill>
+                <a:srgbClr val="052A48"/>
+              </a:solidFill>
+              <a:ln w="38100" cmpd="sng">
+                <a:solidFill>
+                  <a:schemeClr val="bg1"/>
+                </a:solidFill>
+              </a:ln>
+              <a:effectLst/>
+            </p:spPr>
+            <p:style>
+              <a:lnRef idx="1">
+                <a:schemeClr val="accent1"/>
+              </a:lnRef>
+              <a:fillRef idx="3">
+                <a:schemeClr val="accent1"/>
+              </a:fillRef>
+              <a:effectRef idx="2">
+                <a:schemeClr val="accent1"/>
+              </a:effectRef>
+              <a:fontRef idx="minor">
+                <a:schemeClr val="lt1"/>
+              </a:fontRef>
+            </p:style>
+            <p:txBody>
+              <a:bodyPr rtlCol="0" anchor="ctr"/>
+              <a:lstStyle/>
+              <a:p>
+                <a:pPr algn="ctr"/>
+                <a:r>
+                  <a:rPr lang="en-US" sz="2000" u="sng" dirty="0"/>
+                  <a:t>					   </a:t>
+                </a:r>
+              </a:p>
+            </p:txBody>
+          </p:sp>
+          <p:sp>
+            <p:nvSpPr>
+              <p:cNvPr id="11" name="Oval 10">
+                <a:extLst>
+                  <a:ext uri="{FF2B5EF4-FFF2-40B4-BE49-F238E27FC236}">
+                    <a16:creationId xmlns:a16="http://schemas.microsoft.com/office/drawing/2014/main" id="{37F0ABB3-899E-7560-080B-F29287B67C30}"/>
+                  </a:ext>
+                </a:extLst>
+              </p:cNvPr>
+              <p:cNvSpPr/>
+              <p:nvPr/>
+            </p:nvSpPr>
+            <p:spPr>
+              <a:xfrm>
+                <a:off x="1544285" y="1840138"/>
+                <a:ext cx="2478024" cy="2481818"/>
+              </a:xfrm>
+              <a:prstGeom prst="ellipse">
+                <a:avLst/>
+              </a:prstGeom>
+              <a:solidFill>
+                <a:schemeClr val="bg1"/>
+              </a:solidFill>
+              <a:ln w="76200" cmpd="sng">
+                <a:solidFill>
+                  <a:srgbClr val="052A48"/>
+                </a:solidFill>
+              </a:ln>
+              <a:effectLst/>
+            </p:spPr>
+            <p:style>
+              <a:lnRef idx="1">
+                <a:schemeClr val="accent1"/>
+              </a:lnRef>
+              <a:fillRef idx="3">
+                <a:schemeClr val="accent1"/>
+              </a:fillRef>
+              <a:effectRef idx="2">
+                <a:schemeClr val="accent1"/>
+              </a:effectRef>
+              <a:fontRef idx="minor">
+                <a:schemeClr val="lt1"/>
+              </a:fontRef>
+            </p:style>
+            <p:txBody>
+              <a:bodyPr rtlCol="0" anchor="ctr"/>
+              <a:lstStyle/>
+              <a:p>
+                <a:endParaRPr lang="en-US" sz="4400" dirty="0"/>
+              </a:p>
+            </p:txBody>
+          </p:sp>
+          <p:pic>
+            <p:nvPicPr>
+              <p:cNvPr id="12" name="Picture 11" descr="logo_brain_transp_512x512.png">
+                <a:extLst>
+                  <a:ext uri="{FF2B5EF4-FFF2-40B4-BE49-F238E27FC236}">
+                    <a16:creationId xmlns:a16="http://schemas.microsoft.com/office/drawing/2014/main" id="{7DAA6B1B-308F-5B04-63BD-92071CA90C1A}"/>
+                  </a:ext>
+                </a:extLst>
+              </p:cNvPr>
+              <p:cNvPicPr>
+                <a:picLocks noChangeAspect="1"/>
+              </p:cNvPicPr>
+              <p:nvPr/>
+            </p:nvPicPr>
+            <p:blipFill>
+              <a:blip r:embed="rId2">
+                <a:extLst>
+                  <a:ext uri="{28A0092B-C50C-407E-A947-70E740481C1C}">
+                    <a14:useLocalDpi xmlns:a14="http://schemas.microsoft.com/office/drawing/2010/main" val="0"/>
+                  </a:ext>
+                </a:extLst>
+              </a:blip>
+              <a:stretch>
+                <a:fillRect/>
+              </a:stretch>
+            </p:blipFill>
+            <p:spPr>
+              <a:xfrm>
+                <a:off x="1776922" y="2065594"/>
+                <a:ext cx="2154717" cy="2154717"/>
+              </a:xfrm>
+              <a:prstGeom prst="rect">
+                <a:avLst/>
+              </a:prstGeom>
+            </p:spPr>
+          </p:pic>
+        </p:grpSp>
+        <p:pic>
+          <p:nvPicPr>
+            <p:cNvPr id="28" name="Graphic 27">
+              <a:extLst>
+                <a:ext uri="{FF2B5EF4-FFF2-40B4-BE49-F238E27FC236}">
+                  <a16:creationId xmlns:a16="http://schemas.microsoft.com/office/drawing/2014/main" id="{4F21AB3E-9187-B62B-071D-CEFDFEC265A5}"/>
+                </a:ext>
+              </a:extLst>
+            </p:cNvPr>
+            <p:cNvPicPr>
+              <a:picLocks noChangeAspect="1"/>
+            </p:cNvPicPr>
+            <p:nvPr/>
+          </p:nvPicPr>
+          <p:blipFill>
+            <a:blip r:embed="rId3">
+              <a:extLst>
+                <a:ext uri="{28A0092B-C50C-407E-A947-70E740481C1C}">
+                  <a14:useLocalDpi xmlns:a14="http://schemas.microsoft.com/office/drawing/2010/main" val="0"/>
+                </a:ext>
+                <a:ext uri="{96DAC541-7B7A-43D3-8B79-37D633B846F1}">
+                  <asvg:svgBlip xmlns:asvg="http://schemas.microsoft.com/office/drawing/2016/SVG/main" r:embed="rId4"/>
+                </a:ext>
+              </a:extLst>
+            </a:blip>
+            <a:stretch>
+              <a:fillRect/>
+            </a:stretch>
+          </p:blipFill>
+          <p:spPr>
+            <a:xfrm>
+              <a:off x="3403363" y="4040966"/>
+              <a:ext cx="731520" cy="731520"/>
+            </a:xfrm>
+            <a:prstGeom prst="rect">
+              <a:avLst/>
+            </a:prstGeom>
+          </p:spPr>
+        </p:pic>
+      </p:grpSp>
+      <p:grpSp>
+        <p:nvGrpSpPr>
+          <p:cNvPr id="30" name="Group 29">
+            <a:extLst>
+              <a:ext uri="{FF2B5EF4-FFF2-40B4-BE49-F238E27FC236}">
+                <a16:creationId xmlns:a16="http://schemas.microsoft.com/office/drawing/2014/main" id="{115ED77B-9C38-C544-5FF7-C751FD544198}"/>
+              </a:ext>
+            </a:extLst>
+          </p:cNvPr>
+          <p:cNvGrpSpPr/>
+          <p:nvPr/>
+        </p:nvGrpSpPr>
+        <p:grpSpPr>
+          <a:xfrm>
+            <a:off x="1845798" y="3009793"/>
+            <a:ext cx="1973342" cy="2103826"/>
+            <a:chOff x="1845798" y="3009793"/>
+            <a:chExt cx="1973342" cy="2103826"/>
+          </a:xfrm>
+        </p:grpSpPr>
+        <p:grpSp>
+          <p:nvGrpSpPr>
+            <p:cNvPr id="13" name="Group 12">
+              <a:extLst>
+                <a:ext uri="{FF2B5EF4-FFF2-40B4-BE49-F238E27FC236}">
+                  <a16:creationId xmlns:a16="http://schemas.microsoft.com/office/drawing/2014/main" id="{B2E4F815-A6AB-2E3D-7B1B-3124D316CAE4}"/>
+                </a:ext>
+              </a:extLst>
+            </p:cNvPr>
+            <p:cNvGrpSpPr>
+              <a:grpSpLocks noChangeAspect="1"/>
+            </p:cNvGrpSpPr>
+            <p:nvPr/>
+          </p:nvGrpSpPr>
+          <p:grpSpPr>
+            <a:xfrm>
+              <a:off x="1845798" y="3009793"/>
+              <a:ext cx="1834490" cy="1875247"/>
+              <a:chOff x="1544285" y="1840138"/>
+              <a:chExt cx="3619837" cy="3700267"/>
+            </a:xfrm>
+          </p:grpSpPr>
+          <p:sp>
+            <p:nvSpPr>
+              <p:cNvPr id="14" name="Folded Corner 13">
+                <a:extLst>
+                  <a:ext uri="{FF2B5EF4-FFF2-40B4-BE49-F238E27FC236}">
+                    <a16:creationId xmlns:a16="http://schemas.microsoft.com/office/drawing/2014/main" id="{35FE6374-9C6A-E938-E245-B8EE342170FF}"/>
+                  </a:ext>
+                </a:extLst>
+              </p:cNvPr>
+              <p:cNvSpPr/>
+              <p:nvPr/>
+            </p:nvSpPr>
+            <p:spPr>
+              <a:xfrm rot="10800000" flipH="1">
+                <a:off x="2674223" y="2150156"/>
+                <a:ext cx="2489899" cy="3390249"/>
+              </a:xfrm>
+              <a:prstGeom prst="foldedCorner">
+                <a:avLst>
+                  <a:gd name="adj" fmla="val 26556"/>
+                </a:avLst>
+              </a:prstGeom>
+              <a:solidFill>
+                <a:srgbClr val="052A48"/>
+              </a:solidFill>
+              <a:ln w="38100" cmpd="sng">
+                <a:solidFill>
+                  <a:schemeClr val="bg1"/>
+                </a:solidFill>
+              </a:ln>
+              <a:effectLst/>
+            </p:spPr>
+            <p:style>
+              <a:lnRef idx="1">
+                <a:schemeClr val="accent1"/>
+              </a:lnRef>
+              <a:fillRef idx="3">
+                <a:schemeClr val="accent1"/>
+              </a:fillRef>
+              <a:effectRef idx="2">
+                <a:schemeClr val="accent1"/>
+              </a:effectRef>
+              <a:fontRef idx="minor">
+                <a:schemeClr val="lt1"/>
+              </a:fontRef>
+            </p:style>
+            <p:txBody>
+              <a:bodyPr rtlCol="0" anchor="ctr"/>
+              <a:lstStyle/>
+              <a:p>
+                <a:pPr algn="ctr"/>
+                <a:r>
+                  <a:rPr lang="en-US" sz="2000" u="sng" dirty="0"/>
+                  <a:t>					   </a:t>
+                </a:r>
+              </a:p>
+            </p:txBody>
+          </p:sp>
+          <p:sp>
+            <p:nvSpPr>
+              <p:cNvPr id="15" name="Oval 14">
+                <a:extLst>
+                  <a:ext uri="{FF2B5EF4-FFF2-40B4-BE49-F238E27FC236}">
+                    <a16:creationId xmlns:a16="http://schemas.microsoft.com/office/drawing/2014/main" id="{08FC520F-63D4-A9E1-AD47-C7FA0B85404C}"/>
+                  </a:ext>
+                </a:extLst>
+              </p:cNvPr>
+              <p:cNvSpPr/>
+              <p:nvPr/>
+            </p:nvSpPr>
+            <p:spPr>
+              <a:xfrm>
+                <a:off x="1544285" y="1840138"/>
+                <a:ext cx="2478024" cy="2481818"/>
+              </a:xfrm>
+              <a:prstGeom prst="ellipse">
+                <a:avLst/>
+              </a:prstGeom>
+              <a:solidFill>
+                <a:schemeClr val="bg1"/>
+              </a:solidFill>
+              <a:ln w="76200" cmpd="sng">
+                <a:solidFill>
+                  <a:srgbClr val="052A48"/>
+                </a:solidFill>
+              </a:ln>
+              <a:effectLst/>
+            </p:spPr>
+            <p:style>
+              <a:lnRef idx="1">
+                <a:schemeClr val="accent1"/>
+              </a:lnRef>
+              <a:fillRef idx="3">
+                <a:schemeClr val="accent1"/>
+              </a:fillRef>
+              <a:effectRef idx="2">
+                <a:schemeClr val="accent1"/>
+              </a:effectRef>
+              <a:fontRef idx="minor">
+                <a:schemeClr val="lt1"/>
+              </a:fontRef>
+            </p:style>
+            <p:txBody>
+              <a:bodyPr rtlCol="0" anchor="ctr"/>
+              <a:lstStyle/>
+              <a:p>
+                <a:endParaRPr lang="en-US" sz="4400" dirty="0"/>
+              </a:p>
+            </p:txBody>
+          </p:sp>
+          <p:pic>
+            <p:nvPicPr>
+              <p:cNvPr id="16" name="Picture 15" descr="logo_brain_transp_512x512.png">
+                <a:extLst>
+                  <a:ext uri="{FF2B5EF4-FFF2-40B4-BE49-F238E27FC236}">
+                    <a16:creationId xmlns:a16="http://schemas.microsoft.com/office/drawing/2014/main" id="{D0C57689-9937-675F-4B4E-DE5B244302EA}"/>
+                  </a:ext>
+                </a:extLst>
+              </p:cNvPr>
+              <p:cNvPicPr>
+                <a:picLocks noChangeAspect="1"/>
+              </p:cNvPicPr>
+              <p:nvPr/>
+            </p:nvPicPr>
+            <p:blipFill>
+              <a:blip r:embed="rId2">
+                <a:extLst>
+                  <a:ext uri="{28A0092B-C50C-407E-A947-70E740481C1C}">
+                    <a14:useLocalDpi xmlns:a14="http://schemas.microsoft.com/office/drawing/2010/main" val="0"/>
+                  </a:ext>
+                </a:extLst>
+              </a:blip>
+              <a:stretch>
+                <a:fillRect/>
+              </a:stretch>
+            </p:blipFill>
+            <p:spPr>
+              <a:xfrm>
+                <a:off x="1776923" y="2065594"/>
+                <a:ext cx="2154717" cy="2154718"/>
+              </a:xfrm>
+              <a:prstGeom prst="rect">
+                <a:avLst/>
+              </a:prstGeom>
+            </p:spPr>
+          </p:pic>
+        </p:grpSp>
+        <p:pic>
+          <p:nvPicPr>
+            <p:cNvPr id="25" name="Graphic 24">
+              <a:extLst>
+                <a:ext uri="{FF2B5EF4-FFF2-40B4-BE49-F238E27FC236}">
+                  <a16:creationId xmlns:a16="http://schemas.microsoft.com/office/drawing/2014/main" id="{8535795A-6B29-A80E-323A-376985343170}"/>
+                </a:ext>
+              </a:extLst>
+            </p:cNvPr>
+            <p:cNvPicPr>
+              <a:picLocks noChangeAspect="1"/>
+            </p:cNvPicPr>
+            <p:nvPr/>
+          </p:nvPicPr>
+          <p:blipFill>
+            <a:blip r:embed="rId3">
+              <a:extLst>
+                <a:ext uri="{28A0092B-C50C-407E-A947-70E740481C1C}">
+                  <a14:useLocalDpi xmlns:a14="http://schemas.microsoft.com/office/drawing/2010/main" val="0"/>
+                </a:ext>
+                <a:ext uri="{96DAC541-7B7A-43D3-8B79-37D633B846F1}">
+                  <asvg:svgBlip xmlns:asvg="http://schemas.microsoft.com/office/drawing/2016/SVG/main" r:embed="rId4"/>
+                </a:ext>
+              </a:extLst>
+            </a:blip>
+            <a:stretch>
+              <a:fillRect/>
+            </a:stretch>
+          </p:blipFill>
+          <p:spPr>
+            <a:xfrm>
+              <a:off x="3087620" y="4382099"/>
+              <a:ext cx="731520" cy="731520"/>
+            </a:xfrm>
+            <a:prstGeom prst="rect">
+              <a:avLst/>
+            </a:prstGeom>
+          </p:spPr>
+        </p:pic>
+      </p:grpSp>
+      <p:sp>
+        <p:nvSpPr>
+          <p:cNvPr id="26" name="Rectangle 25">
+            <a:extLst>
+              <a:ext uri="{FF2B5EF4-FFF2-40B4-BE49-F238E27FC236}">
+                <a16:creationId xmlns:a16="http://schemas.microsoft.com/office/drawing/2014/main" id="{217F646C-9719-14B7-7C33-4C1EDEE3A37C}"/>
+              </a:ext>
+            </a:extLst>
+          </p:cNvPr>
+          <p:cNvSpPr/>
+          <p:nvPr/>
+        </p:nvSpPr>
+        <p:spPr>
+          <a:xfrm>
+            <a:off x="863980" y="855015"/>
+            <a:ext cx="7213708" cy="1754326"/>
+          </a:xfrm>
+          <a:prstGeom prst="rect">
+            <a:avLst/>
+          </a:prstGeom>
+        </p:spPr>
+        <p:txBody>
+          <a:bodyPr wrap="square">
+            <a:spAutoFit/>
+          </a:bodyPr>
+          <a:lstStyle/>
+          <a:p>
+            <a:pPr algn="ctr"/>
+            <a:r>
+              <a:rPr lang="en-US" sz="5400" b="1" dirty="0">
+                <a:solidFill>
+                  <a:srgbClr val="052B48"/>
+                </a:solidFill>
+                <a:latin typeface="Calibri"/>
+                <a:cs typeface="Calibri"/>
+              </a:rPr>
+              <a:t>Annotating Multiple NWB Files with HERD</a:t>
+            </a:r>
+          </a:p>
+        </p:txBody>
+      </p:sp>
+      <p:pic>
+        <p:nvPicPr>
+          <p:cNvPr id="21" name="Picture 20" descr="www-1632431_1280.png">
+            <a:extLst>
+              <a:ext uri="{FF2B5EF4-FFF2-40B4-BE49-F238E27FC236}">
+                <a16:creationId xmlns:a16="http://schemas.microsoft.com/office/drawing/2014/main" id="{BD7938F2-685D-6557-E8D5-8C6C4315FE80}"/>
+              </a:ext>
+            </a:extLst>
+          </p:cNvPr>
+          <p:cNvPicPr>
+            <a:picLocks noChangeAspect="1"/>
+          </p:cNvPicPr>
+          <p:nvPr/>
+        </p:nvPicPr>
+        <p:blipFill>
+          <a:blip r:embed="rId5">
+            <a:duotone>
+              <a:schemeClr val="accent5">
+                <a:shade val="45000"/>
+                <a:satMod val="135000"/>
+              </a:schemeClr>
+              <a:prstClr val="white"/>
+            </a:duotone>
+            <a:extLst>
+              <a:ext uri="{28A0092B-C50C-407E-A947-70E740481C1C}">
+                <a14:useLocalDpi xmlns:a14="http://schemas.microsoft.com/office/drawing/2010/main" val="0"/>
+              </a:ext>
+            </a:extLst>
+          </a:blip>
+          <a:stretch>
+            <a:fillRect/>
+          </a:stretch>
+        </p:blipFill>
+        <p:spPr>
+          <a:xfrm>
+            <a:off x="5452853" y="3018310"/>
+            <a:ext cx="1920497" cy="1866483"/>
+          </a:xfrm>
+          <a:prstGeom prst="rect">
+            <a:avLst/>
+          </a:prstGeom>
+        </p:spPr>
+      </p:pic>
+      <p:sp>
+        <p:nvSpPr>
+          <p:cNvPr id="22" name="Left Arrow 21">
+            <a:extLst>
+              <a:ext uri="{FF2B5EF4-FFF2-40B4-BE49-F238E27FC236}">
+                <a16:creationId xmlns:a16="http://schemas.microsoft.com/office/drawing/2014/main" id="{A3EA5341-11A6-7B92-CA95-CFF425CCD66E}"/>
+              </a:ext>
+            </a:extLst>
+          </p:cNvPr>
+          <p:cNvSpPr/>
+          <p:nvPr/>
+        </p:nvSpPr>
+        <p:spPr>
+          <a:xfrm rot="10800000" flipV="1">
+            <a:off x="4205223" y="3740567"/>
+            <a:ext cx="1122271" cy="421971"/>
+          </a:xfrm>
+          <a:prstGeom prst="leftArrow">
+            <a:avLst>
+              <a:gd name="adj1" fmla="val 46274"/>
+              <a:gd name="adj2" fmla="val 162557"/>
+            </a:avLst>
+          </a:prstGeom>
+          <a:solidFill>
+            <a:srgbClr val="D17128"/>
+          </a:solidFill>
+          <a:ln w="9525" cmpd="sng">
+            <a:noFill/>
+          </a:ln>
+        </p:spPr>
+        <p:style>
+          <a:lnRef idx="0">
+            <a:schemeClr val="accent1">
+              <a:tint val="60000"/>
+              <a:hueOff val="0"/>
+              <a:satOff val="0"/>
+              <a:lumOff val="0"/>
+              <a:alphaOff val="0"/>
+            </a:schemeClr>
+          </a:lnRef>
+          <a:fillRef idx="1">
+            <a:schemeClr val="accent1">
+              <a:tint val="60000"/>
+              <a:hueOff val="0"/>
+              <a:satOff val="0"/>
+              <a:lumOff val="0"/>
+              <a:alphaOff val="0"/>
+            </a:schemeClr>
+          </a:fillRef>
+          <a:effectRef idx="0">
+            <a:schemeClr val="accent1">
+              <a:tint val="60000"/>
+              <a:hueOff val="0"/>
+              <a:satOff val="0"/>
+              <a:lumOff val="0"/>
+              <a:alphaOff val="0"/>
+            </a:schemeClr>
+          </a:effectRef>
+          <a:fontRef idx="minor">
+            <a:schemeClr val="lt1"/>
+          </a:fontRef>
+        </p:style>
+        <p:txBody>
+          <a:bodyPr/>
+          <a:lstStyle/>
+          <a:p>
+            <a:endParaRPr lang="en-US"/>
+          </a:p>
+        </p:txBody>
+      </p:sp>
+      <p:pic>
+        <p:nvPicPr>
+          <p:cNvPr id="24" name="Graphic 23">
+            <a:extLst>
+              <a:ext uri="{FF2B5EF4-FFF2-40B4-BE49-F238E27FC236}">
+                <a16:creationId xmlns:a16="http://schemas.microsoft.com/office/drawing/2014/main" id="{8E87B66D-16A5-64DE-C5B2-0C41C3A69397}"/>
+              </a:ext>
+            </a:extLst>
+          </p:cNvPr>
+          <p:cNvPicPr>
+            <a:picLocks noChangeAspect="1"/>
+          </p:cNvPicPr>
+          <p:nvPr/>
+        </p:nvPicPr>
+        <p:blipFill>
+          <a:blip r:embed="rId6">
+            <a:extLst>
+              <a:ext uri="{28A0092B-C50C-407E-A947-70E740481C1C}">
+                <a14:useLocalDpi xmlns:a14="http://schemas.microsoft.com/office/drawing/2010/main" val="0"/>
+              </a:ext>
+              <a:ext uri="{96DAC541-7B7A-43D3-8B79-37D633B846F1}">
+                <asvg:svgBlip xmlns:asvg="http://schemas.microsoft.com/office/drawing/2016/SVG/main" r:embed="rId7"/>
+              </a:ext>
+            </a:extLst>
+          </a:blip>
+          <a:stretch>
+            <a:fillRect/>
+          </a:stretch>
+        </p:blipFill>
+        <p:spPr>
+          <a:xfrm>
+            <a:off x="4442691" y="3277250"/>
+            <a:ext cx="431505" cy="431505"/>
+          </a:xfrm>
+          <a:prstGeom prst="rect">
+            <a:avLst/>
+          </a:prstGeom>
+        </p:spPr>
+      </p:pic>
+      <p:grpSp>
+        <p:nvGrpSpPr>
+          <p:cNvPr id="31" name="Group 30">
+            <a:extLst>
+              <a:ext uri="{FF2B5EF4-FFF2-40B4-BE49-F238E27FC236}">
+                <a16:creationId xmlns:a16="http://schemas.microsoft.com/office/drawing/2014/main" id="{0B4FAD6D-8680-1D9C-0A14-EC1660E9DD12}"/>
+              </a:ext>
+            </a:extLst>
+          </p:cNvPr>
+          <p:cNvGrpSpPr/>
+          <p:nvPr/>
+        </p:nvGrpSpPr>
+        <p:grpSpPr>
+          <a:xfrm>
+            <a:off x="1514727" y="3335890"/>
+            <a:ext cx="1985884" cy="2103826"/>
+            <a:chOff x="1514727" y="3335890"/>
+            <a:chExt cx="1985884" cy="2103826"/>
+          </a:xfrm>
+        </p:grpSpPr>
+        <p:grpSp>
+          <p:nvGrpSpPr>
+            <p:cNvPr id="17" name="Group 16">
+              <a:extLst>
+                <a:ext uri="{FF2B5EF4-FFF2-40B4-BE49-F238E27FC236}">
+                  <a16:creationId xmlns:a16="http://schemas.microsoft.com/office/drawing/2014/main" id="{437FFF61-EE99-4FE7-68DC-0CA6327A7F5D}"/>
+                </a:ext>
+              </a:extLst>
+            </p:cNvPr>
+            <p:cNvGrpSpPr>
+              <a:grpSpLocks noChangeAspect="1"/>
+            </p:cNvGrpSpPr>
+            <p:nvPr/>
+          </p:nvGrpSpPr>
+          <p:grpSpPr>
+            <a:xfrm>
+              <a:off x="1514727" y="3335890"/>
+              <a:ext cx="1834490" cy="1875247"/>
+              <a:chOff x="1544285" y="1840138"/>
+              <a:chExt cx="3619836" cy="3700266"/>
+            </a:xfrm>
+          </p:grpSpPr>
+          <p:sp>
+            <p:nvSpPr>
+              <p:cNvPr id="18" name="Folded Corner 17">
+                <a:extLst>
+                  <a:ext uri="{FF2B5EF4-FFF2-40B4-BE49-F238E27FC236}">
+                    <a16:creationId xmlns:a16="http://schemas.microsoft.com/office/drawing/2014/main" id="{55ED054F-69D1-E6E1-8C17-20E0D357FCBE}"/>
+                  </a:ext>
+                </a:extLst>
+              </p:cNvPr>
+              <p:cNvSpPr/>
+              <p:nvPr/>
+            </p:nvSpPr>
+            <p:spPr>
+              <a:xfrm rot="10800000" flipH="1">
+                <a:off x="2674222" y="2150156"/>
+                <a:ext cx="2489899" cy="3390248"/>
+              </a:xfrm>
+              <a:prstGeom prst="foldedCorner">
+                <a:avLst>
+                  <a:gd name="adj" fmla="val 26556"/>
+                </a:avLst>
+              </a:prstGeom>
+              <a:solidFill>
+                <a:srgbClr val="052A48"/>
+              </a:solidFill>
+              <a:ln w="38100" cmpd="sng">
+                <a:solidFill>
+                  <a:schemeClr val="bg1"/>
+                </a:solidFill>
+              </a:ln>
+              <a:effectLst/>
+            </p:spPr>
+            <p:style>
+              <a:lnRef idx="1">
+                <a:schemeClr val="accent1"/>
+              </a:lnRef>
+              <a:fillRef idx="3">
+                <a:schemeClr val="accent1"/>
+              </a:fillRef>
+              <a:effectRef idx="2">
+                <a:schemeClr val="accent1"/>
+              </a:effectRef>
+              <a:fontRef idx="minor">
+                <a:schemeClr val="lt1"/>
+              </a:fontRef>
+            </p:style>
+            <p:txBody>
+              <a:bodyPr rtlCol="0" anchor="ctr"/>
+              <a:lstStyle/>
+              <a:p>
+                <a:pPr algn="ctr"/>
+                <a:r>
+                  <a:rPr lang="en-US" sz="2000" u="sng" dirty="0"/>
+                  <a:t>					   </a:t>
+                </a:r>
+              </a:p>
+            </p:txBody>
+          </p:sp>
+          <p:sp>
+            <p:nvSpPr>
+              <p:cNvPr id="19" name="Oval 18">
+                <a:extLst>
+                  <a:ext uri="{FF2B5EF4-FFF2-40B4-BE49-F238E27FC236}">
+                    <a16:creationId xmlns:a16="http://schemas.microsoft.com/office/drawing/2014/main" id="{17003DBB-4827-5518-5E7D-1F751E6A78A0}"/>
+                  </a:ext>
+                </a:extLst>
+              </p:cNvPr>
+              <p:cNvSpPr/>
+              <p:nvPr/>
+            </p:nvSpPr>
+            <p:spPr>
+              <a:xfrm>
+                <a:off x="1544285" y="1840138"/>
+                <a:ext cx="2478024" cy="2481818"/>
+              </a:xfrm>
+              <a:prstGeom prst="ellipse">
+                <a:avLst/>
+              </a:prstGeom>
+              <a:solidFill>
+                <a:schemeClr val="bg1"/>
+              </a:solidFill>
+              <a:ln w="76200" cmpd="sng">
+                <a:solidFill>
+                  <a:srgbClr val="052A48"/>
+                </a:solidFill>
+              </a:ln>
+              <a:effectLst/>
+            </p:spPr>
+            <p:style>
+              <a:lnRef idx="1">
+                <a:schemeClr val="accent1"/>
+              </a:lnRef>
+              <a:fillRef idx="3">
+                <a:schemeClr val="accent1"/>
+              </a:fillRef>
+              <a:effectRef idx="2">
+                <a:schemeClr val="accent1"/>
+              </a:effectRef>
+              <a:fontRef idx="minor">
+                <a:schemeClr val="lt1"/>
+              </a:fontRef>
+            </p:style>
+            <p:txBody>
+              <a:bodyPr rtlCol="0" anchor="ctr"/>
+              <a:lstStyle/>
+              <a:p>
+                <a:endParaRPr lang="en-US" sz="4400" dirty="0"/>
+              </a:p>
+            </p:txBody>
+          </p:sp>
+          <p:pic>
+            <p:nvPicPr>
+              <p:cNvPr id="20" name="Picture 19" descr="logo_brain_transp_512x512.png">
+                <a:extLst>
+                  <a:ext uri="{FF2B5EF4-FFF2-40B4-BE49-F238E27FC236}">
+                    <a16:creationId xmlns:a16="http://schemas.microsoft.com/office/drawing/2014/main" id="{9647747D-62FE-EA69-E5CD-63F40BFDC3D0}"/>
+                  </a:ext>
+                </a:extLst>
+              </p:cNvPr>
+              <p:cNvPicPr>
+                <a:picLocks noChangeAspect="1"/>
+              </p:cNvPicPr>
+              <p:nvPr/>
+            </p:nvPicPr>
+            <p:blipFill>
+              <a:blip r:embed="rId2">
+                <a:extLst>
+                  <a:ext uri="{28A0092B-C50C-407E-A947-70E740481C1C}">
+                    <a14:useLocalDpi xmlns:a14="http://schemas.microsoft.com/office/drawing/2010/main" val="0"/>
+                  </a:ext>
+                </a:extLst>
+              </a:blip>
+              <a:stretch>
+                <a:fillRect/>
+              </a:stretch>
+            </p:blipFill>
+            <p:spPr>
+              <a:xfrm>
+                <a:off x="1776922" y="2065594"/>
+                <a:ext cx="2154717" cy="2154717"/>
+              </a:xfrm>
+              <a:prstGeom prst="rect">
+                <a:avLst/>
+              </a:prstGeom>
+            </p:spPr>
+          </p:pic>
+        </p:grpSp>
+        <p:pic>
+          <p:nvPicPr>
+            <p:cNvPr id="8" name="Graphic 7">
+              <a:extLst>
+                <a:ext uri="{FF2B5EF4-FFF2-40B4-BE49-F238E27FC236}">
+                  <a16:creationId xmlns:a16="http://schemas.microsoft.com/office/drawing/2014/main" id="{B7D15FAF-23C4-0E1B-46CB-76029B0172F5}"/>
+                </a:ext>
+              </a:extLst>
+            </p:cNvPr>
+            <p:cNvPicPr>
+              <a:picLocks noChangeAspect="1"/>
+            </p:cNvPicPr>
+            <p:nvPr/>
+          </p:nvPicPr>
+          <p:blipFill>
+            <a:blip r:embed="rId3">
+              <a:extLst>
+                <a:ext uri="{28A0092B-C50C-407E-A947-70E740481C1C}">
+                  <a14:useLocalDpi xmlns:a14="http://schemas.microsoft.com/office/drawing/2010/main" val="0"/>
+                </a:ext>
+                <a:ext uri="{96DAC541-7B7A-43D3-8B79-37D633B846F1}">
+                  <asvg:svgBlip xmlns:asvg="http://schemas.microsoft.com/office/drawing/2016/SVG/main" r:embed="rId4"/>
+                </a:ext>
+              </a:extLst>
+            </a:blip>
+            <a:stretch>
+              <a:fillRect/>
+            </a:stretch>
+          </p:blipFill>
+          <p:spPr>
+            <a:xfrm>
+              <a:off x="2769091" y="4708196"/>
+              <a:ext cx="731520" cy="731520"/>
+            </a:xfrm>
+            <a:prstGeom prst="rect">
+              <a:avLst/>
+            </a:prstGeom>
+          </p:spPr>
+        </p:pic>
+      </p:grpSp>
+    </p:spTree>
+    <p:extLst>
+      <p:ext uri="{BB962C8B-B14F-4D97-AF65-F5344CB8AC3E}">
+        <p14:creationId xmlns:p14="http://schemas.microsoft.com/office/powerpoint/2010/main" val="3382530033"/>
+      </p:ext>
+    </p:extLst>
+  </p:cSld>
+  <p:clrMapOvr>
+    <a:masterClrMapping/>
+  </p:clrMapOvr>
+</p:sld>
+</file>
+
 <file path=ppt/slides/slide3.xml><?xml version="1.0" encoding="utf-8"?>
 <p:sld xmlns:a="http://schemas.openxmlformats.org/drawingml/2006/main" xmlns:r="http://schemas.openxmlformats.org/officeDocument/2006/relationships" xmlns:p="http://schemas.openxmlformats.org/presentationml/2006/main">
   <p:cSld>

</xml_diff>

<commit_message>
Add HERD tutorial and DANDI streaming example (#2200)
Co-authored-by: Matthew Avaylon <22578631+mavaylon1@users.noreply.github.com>
Co-authored-by: Claude Opus 4.8 (1M context) <noreply@anthropic.com>
Co-authored-by: Ben Dichter <ben.dichter@gmail.com>
Co-authored-by: Oliver Ruebel <oruebel@users.noreply.github.com>
</commit_message>
<xml_diff>
--- a/docs/source/figures/gallery_thumbnails.pptx
+++ b/docs/source/figures/gallery_thumbnails.pptx
@@ -5,7 +5,7 @@
     <p:sldMasterId id="2147483660" r:id="rId1"/>
   </p:sldMasterIdLst>
   <p:notesMasterIdLst>
-    <p:notesMasterId r:id="rId22"/>
+    <p:notesMasterId r:id="rId24"/>
   </p:notesMasterIdLst>
   <p:sldIdLst>
     <p:sldId id="342" r:id="rId2"/>
@@ -28,6 +28,8 @@
     <p:sldId id="359" r:id="rId19"/>
     <p:sldId id="366" r:id="rId20"/>
     <p:sldId id="367" r:id="rId21"/>
+    <p:sldId id="368" r:id="rId22"/>
+    <p:sldId id="369" r:id="rId23"/>
   </p:sldIdLst>
   <p:sldSz cx="12192000" cy="6858000"/>
   <p:notesSz cx="6858000" cy="9144000"/>
@@ -227,7 +229,7 @@
           <a:p>
             <a:fld id="{4D6A40B9-902A-4E0E-AF39-1C357549AEE0}" type="datetimeFigureOut">
               <a:rPr lang="en-US" smtClean="0"/>
-              <a:t>11/7/24</a:t>
+              <a:t>6/22/26</a:t>
             </a:fld>
             <a:endParaRPr lang="en-US"/>
           </a:p>
@@ -9445,6 +9447,1152 @@
 </p:sld>
 </file>
 
+<file path=ppt/slides/slide21.xml><?xml version="1.0" encoding="utf-8"?>
+<p:sld xmlns:a="http://schemas.openxmlformats.org/drawingml/2006/main" xmlns:r="http://schemas.openxmlformats.org/officeDocument/2006/relationships" xmlns:p="http://schemas.openxmlformats.org/presentationml/2006/main">
+  <p:cSld>
+    <p:spTree>
+      <p:nvGrpSpPr>
+        <p:cNvPr id="1" name="">
+          <a:extLst>
+            <a:ext uri="{FF2B5EF4-FFF2-40B4-BE49-F238E27FC236}">
+              <a16:creationId xmlns:a16="http://schemas.microsoft.com/office/drawing/2014/main" id="{71E4B4A6-73B7-86C7-8670-46D8D41DD2E0}"/>
+            </a:ext>
+          </a:extLst>
+        </p:cNvPr>
+        <p:cNvGrpSpPr/>
+        <p:nvPr/>
+      </p:nvGrpSpPr>
+      <p:grpSpPr>
+        <a:xfrm>
+          <a:off x="0" y="0"/>
+          <a:ext cx="0" cy="0"/>
+          <a:chOff x="0" y="0"/>
+          <a:chExt cx="0" cy="0"/>
+        </a:xfrm>
+      </p:grpSpPr>
+      <p:sp>
+        <p:nvSpPr>
+          <p:cNvPr id="27" name="Rounded Rectangle 26">
+            <a:extLst>
+              <a:ext uri="{FF2B5EF4-FFF2-40B4-BE49-F238E27FC236}">
+                <a16:creationId xmlns:a16="http://schemas.microsoft.com/office/drawing/2014/main" id="{5BC30344-1E85-01AE-B374-65D2A28A5CE4}"/>
+              </a:ext>
+            </a:extLst>
+          </p:cNvPr>
+          <p:cNvSpPr/>
+          <p:nvPr/>
+        </p:nvSpPr>
+        <p:spPr>
+          <a:xfrm>
+            <a:off x="853570" y="853671"/>
+            <a:ext cx="7234527" cy="4851352"/>
+          </a:xfrm>
+          <a:prstGeom prst="roundRect">
+            <a:avLst>
+              <a:gd name="adj" fmla="val 4437"/>
+            </a:avLst>
+          </a:prstGeom>
+          <a:solidFill>
+            <a:srgbClr val="EDEDED"/>
+          </a:solidFill>
+          <a:ln>
+            <a:solidFill>
+              <a:srgbClr val="000000"/>
+            </a:solidFill>
+          </a:ln>
+          <a:effectLst/>
+        </p:spPr>
+        <p:style>
+          <a:lnRef idx="1">
+            <a:schemeClr val="accent1"/>
+          </a:lnRef>
+          <a:fillRef idx="3">
+            <a:schemeClr val="accent1"/>
+          </a:fillRef>
+          <a:effectRef idx="2">
+            <a:schemeClr val="accent1"/>
+          </a:effectRef>
+          <a:fontRef idx="minor">
+            <a:schemeClr val="lt1"/>
+          </a:fontRef>
+        </p:style>
+        <p:txBody>
+          <a:bodyPr rtlCol="0" anchor="ctr"/>
+          <a:lstStyle/>
+          <a:p>
+            <a:pPr algn="ctr"/>
+            <a:endParaRPr lang="en-US"/>
+          </a:p>
+        </p:txBody>
+      </p:sp>
+      <p:sp>
+        <p:nvSpPr>
+          <p:cNvPr id="26" name="Rectangle 25">
+            <a:extLst>
+              <a:ext uri="{FF2B5EF4-FFF2-40B4-BE49-F238E27FC236}">
+                <a16:creationId xmlns:a16="http://schemas.microsoft.com/office/drawing/2014/main" id="{217F646C-9719-14B7-7C33-4C1EDEE3A37C}"/>
+              </a:ext>
+            </a:extLst>
+          </p:cNvPr>
+          <p:cNvSpPr/>
+          <p:nvPr/>
+        </p:nvSpPr>
+        <p:spPr>
+          <a:xfrm>
+            <a:off x="863980" y="855015"/>
+            <a:ext cx="7213708" cy="1754326"/>
+          </a:xfrm>
+          <a:prstGeom prst="rect">
+            <a:avLst/>
+          </a:prstGeom>
+        </p:spPr>
+        <p:txBody>
+          <a:bodyPr wrap="square">
+            <a:spAutoFit/>
+          </a:bodyPr>
+          <a:lstStyle/>
+          <a:p>
+            <a:pPr algn="ctr"/>
+            <a:r>
+              <a:rPr lang="en-US" sz="5400" b="1" dirty="0">
+                <a:solidFill>
+                  <a:srgbClr val="052B48"/>
+                </a:solidFill>
+                <a:latin typeface="Calibri"/>
+                <a:cs typeface="Calibri"/>
+              </a:rPr>
+              <a:t>Linking to External Resources (HERD)</a:t>
+            </a:r>
+          </a:p>
+        </p:txBody>
+      </p:sp>
+      <p:pic>
+        <p:nvPicPr>
+          <p:cNvPr id="2" name="Picture 1" descr="www-1632431_1280.png">
+            <a:extLst>
+              <a:ext uri="{FF2B5EF4-FFF2-40B4-BE49-F238E27FC236}">
+                <a16:creationId xmlns:a16="http://schemas.microsoft.com/office/drawing/2014/main" id="{93EF452C-A2C7-2115-F3BE-BF48BD25EA11}"/>
+              </a:ext>
+            </a:extLst>
+          </p:cNvPr>
+          <p:cNvPicPr>
+            <a:picLocks noChangeAspect="1"/>
+          </p:cNvPicPr>
+          <p:nvPr/>
+        </p:nvPicPr>
+        <p:blipFill>
+          <a:blip r:embed="rId2">
+            <a:duotone>
+              <a:schemeClr val="accent5">
+                <a:shade val="45000"/>
+                <a:satMod val="135000"/>
+              </a:schemeClr>
+              <a:prstClr val="white"/>
+            </a:duotone>
+            <a:extLst>
+              <a:ext uri="{28A0092B-C50C-407E-A947-70E740481C1C}">
+                <a14:useLocalDpi xmlns:a14="http://schemas.microsoft.com/office/drawing/2010/main" val="0"/>
+              </a:ext>
+            </a:extLst>
+          </a:blip>
+          <a:stretch>
+            <a:fillRect/>
+          </a:stretch>
+        </p:blipFill>
+        <p:spPr>
+          <a:xfrm>
+            <a:off x="3060191" y="2771177"/>
+            <a:ext cx="2824101" cy="2744673"/>
+          </a:xfrm>
+          <a:prstGeom prst="rect">
+            <a:avLst/>
+          </a:prstGeom>
+        </p:spPr>
+      </p:pic>
+    </p:spTree>
+    <p:extLst>
+      <p:ext uri="{BB962C8B-B14F-4D97-AF65-F5344CB8AC3E}">
+        <p14:creationId xmlns:p14="http://schemas.microsoft.com/office/powerpoint/2010/main" val="3871014493"/>
+      </p:ext>
+    </p:extLst>
+  </p:cSld>
+  <p:clrMapOvr>
+    <a:masterClrMapping/>
+  </p:clrMapOvr>
+</p:sld>
+</file>
+
+<file path=ppt/slides/slide22.xml><?xml version="1.0" encoding="utf-8"?>
+<p:sld xmlns:a="http://schemas.openxmlformats.org/drawingml/2006/main" xmlns:r="http://schemas.openxmlformats.org/officeDocument/2006/relationships" xmlns:p="http://schemas.openxmlformats.org/presentationml/2006/main">
+  <p:cSld>
+    <p:spTree>
+      <p:nvGrpSpPr>
+        <p:cNvPr id="1" name="">
+          <a:extLst>
+            <a:ext uri="{FF2B5EF4-FFF2-40B4-BE49-F238E27FC236}">
+              <a16:creationId xmlns:a16="http://schemas.microsoft.com/office/drawing/2014/main" id="{71E4B4A6-73B7-86C7-8670-46D8D41DD2E0}"/>
+            </a:ext>
+          </a:extLst>
+        </p:cNvPr>
+        <p:cNvGrpSpPr/>
+        <p:nvPr/>
+      </p:nvGrpSpPr>
+      <p:grpSpPr>
+        <a:xfrm>
+          <a:off x="0" y="0"/>
+          <a:ext cx="0" cy="0"/>
+          <a:chOff x="0" y="0"/>
+          <a:chExt cx="0" cy="0"/>
+        </a:xfrm>
+      </p:grpSpPr>
+      <p:sp>
+        <p:nvSpPr>
+          <p:cNvPr id="27" name="Rounded Rectangle 26">
+            <a:extLst>
+              <a:ext uri="{FF2B5EF4-FFF2-40B4-BE49-F238E27FC236}">
+                <a16:creationId xmlns:a16="http://schemas.microsoft.com/office/drawing/2014/main" id="{5BC30344-1E85-01AE-B374-65D2A28A5CE4}"/>
+              </a:ext>
+            </a:extLst>
+          </p:cNvPr>
+          <p:cNvSpPr/>
+          <p:nvPr/>
+        </p:nvSpPr>
+        <p:spPr>
+          <a:xfrm>
+            <a:off x="853570" y="853671"/>
+            <a:ext cx="7234527" cy="4851352"/>
+          </a:xfrm>
+          <a:prstGeom prst="roundRect">
+            <a:avLst>
+              <a:gd name="adj" fmla="val 4437"/>
+            </a:avLst>
+          </a:prstGeom>
+          <a:solidFill>
+            <a:srgbClr val="EDEDED"/>
+          </a:solidFill>
+          <a:ln>
+            <a:solidFill>
+              <a:srgbClr val="000000"/>
+            </a:solidFill>
+          </a:ln>
+          <a:effectLst/>
+        </p:spPr>
+        <p:style>
+          <a:lnRef idx="1">
+            <a:schemeClr val="accent1"/>
+          </a:lnRef>
+          <a:fillRef idx="3">
+            <a:schemeClr val="accent1"/>
+          </a:fillRef>
+          <a:effectRef idx="2">
+            <a:schemeClr val="accent1"/>
+          </a:effectRef>
+          <a:fontRef idx="minor">
+            <a:schemeClr val="lt1"/>
+          </a:fontRef>
+        </p:style>
+        <p:txBody>
+          <a:bodyPr rtlCol="0" anchor="ctr"/>
+          <a:lstStyle/>
+          <a:p>
+            <a:pPr algn="ctr"/>
+            <a:endParaRPr lang="en-US"/>
+          </a:p>
+        </p:txBody>
+      </p:sp>
+      <p:grpSp>
+        <p:nvGrpSpPr>
+          <p:cNvPr id="29" name="Group 28">
+            <a:extLst>
+              <a:ext uri="{FF2B5EF4-FFF2-40B4-BE49-F238E27FC236}">
+                <a16:creationId xmlns:a16="http://schemas.microsoft.com/office/drawing/2014/main" id="{0085A170-0FEE-0D68-8BFA-6C4F3670242F}"/>
+              </a:ext>
+            </a:extLst>
+          </p:cNvPr>
+          <p:cNvGrpSpPr/>
+          <p:nvPr/>
+        </p:nvGrpSpPr>
+        <p:grpSpPr>
+          <a:xfrm>
+            <a:off x="2176869" y="2683696"/>
+            <a:ext cx="1958014" cy="2088790"/>
+            <a:chOff x="2176869" y="2683696"/>
+            <a:chExt cx="1958014" cy="2088790"/>
+          </a:xfrm>
+        </p:grpSpPr>
+        <p:grpSp>
+          <p:nvGrpSpPr>
+            <p:cNvPr id="9" name="Group 8">
+              <a:extLst>
+                <a:ext uri="{FF2B5EF4-FFF2-40B4-BE49-F238E27FC236}">
+                  <a16:creationId xmlns:a16="http://schemas.microsoft.com/office/drawing/2014/main" id="{EFABE697-4470-7303-2915-C0BEFA0D1D1A}"/>
+                </a:ext>
+              </a:extLst>
+            </p:cNvPr>
+            <p:cNvGrpSpPr>
+              <a:grpSpLocks noChangeAspect="1"/>
+            </p:cNvGrpSpPr>
+            <p:nvPr/>
+          </p:nvGrpSpPr>
+          <p:grpSpPr>
+            <a:xfrm>
+              <a:off x="2176869" y="2683696"/>
+              <a:ext cx="1834490" cy="1875247"/>
+              <a:chOff x="1544285" y="1840138"/>
+              <a:chExt cx="3619836" cy="3700266"/>
+            </a:xfrm>
+          </p:grpSpPr>
+          <p:sp>
+            <p:nvSpPr>
+              <p:cNvPr id="10" name="Folded Corner 9">
+                <a:extLst>
+                  <a:ext uri="{FF2B5EF4-FFF2-40B4-BE49-F238E27FC236}">
+                    <a16:creationId xmlns:a16="http://schemas.microsoft.com/office/drawing/2014/main" id="{19EBA2B3-8673-CBCC-100B-268475967AC4}"/>
+                  </a:ext>
+                </a:extLst>
+              </p:cNvPr>
+              <p:cNvSpPr/>
+              <p:nvPr/>
+            </p:nvSpPr>
+            <p:spPr>
+              <a:xfrm rot="10800000" flipH="1">
+                <a:off x="2674222" y="2150156"/>
+                <a:ext cx="2489899" cy="3390248"/>
+              </a:xfrm>
+              <a:prstGeom prst="foldedCorner">
+                <a:avLst>
+                  <a:gd name="adj" fmla="val 26556"/>
+                </a:avLst>
+              </a:prstGeom>
+              <a:solidFill>
+                <a:srgbClr val="052A48"/>
+              </a:solidFill>
+              <a:ln w="38100" cmpd="sng">
+                <a:solidFill>
+                  <a:schemeClr val="bg1"/>
+                </a:solidFill>
+              </a:ln>
+              <a:effectLst/>
+            </p:spPr>
+            <p:style>
+              <a:lnRef idx="1">
+                <a:schemeClr val="accent1"/>
+              </a:lnRef>
+              <a:fillRef idx="3">
+                <a:schemeClr val="accent1"/>
+              </a:fillRef>
+              <a:effectRef idx="2">
+                <a:schemeClr val="accent1"/>
+              </a:effectRef>
+              <a:fontRef idx="minor">
+                <a:schemeClr val="lt1"/>
+              </a:fontRef>
+            </p:style>
+            <p:txBody>
+              <a:bodyPr rtlCol="0" anchor="ctr"/>
+              <a:lstStyle/>
+              <a:p>
+                <a:pPr algn="ctr"/>
+                <a:r>
+                  <a:rPr lang="en-US" sz="2000" u="sng" dirty="0"/>
+                  <a:t>					   </a:t>
+                </a:r>
+              </a:p>
+            </p:txBody>
+          </p:sp>
+          <p:sp>
+            <p:nvSpPr>
+              <p:cNvPr id="11" name="Oval 10">
+                <a:extLst>
+                  <a:ext uri="{FF2B5EF4-FFF2-40B4-BE49-F238E27FC236}">
+                    <a16:creationId xmlns:a16="http://schemas.microsoft.com/office/drawing/2014/main" id="{37F0ABB3-899E-7560-080B-F29287B67C30}"/>
+                  </a:ext>
+                </a:extLst>
+              </p:cNvPr>
+              <p:cNvSpPr/>
+              <p:nvPr/>
+            </p:nvSpPr>
+            <p:spPr>
+              <a:xfrm>
+                <a:off x="1544285" y="1840138"/>
+                <a:ext cx="2478024" cy="2481818"/>
+              </a:xfrm>
+              <a:prstGeom prst="ellipse">
+                <a:avLst/>
+              </a:prstGeom>
+              <a:solidFill>
+                <a:schemeClr val="bg1"/>
+              </a:solidFill>
+              <a:ln w="76200" cmpd="sng">
+                <a:solidFill>
+                  <a:srgbClr val="052A48"/>
+                </a:solidFill>
+              </a:ln>
+              <a:effectLst/>
+            </p:spPr>
+            <p:style>
+              <a:lnRef idx="1">
+                <a:schemeClr val="accent1"/>
+              </a:lnRef>
+              <a:fillRef idx="3">
+                <a:schemeClr val="accent1"/>
+              </a:fillRef>
+              <a:effectRef idx="2">
+                <a:schemeClr val="accent1"/>
+              </a:effectRef>
+              <a:fontRef idx="minor">
+                <a:schemeClr val="lt1"/>
+              </a:fontRef>
+            </p:style>
+            <p:txBody>
+              <a:bodyPr rtlCol="0" anchor="ctr"/>
+              <a:lstStyle/>
+              <a:p>
+                <a:endParaRPr lang="en-US" sz="4400" dirty="0"/>
+              </a:p>
+            </p:txBody>
+          </p:sp>
+          <p:pic>
+            <p:nvPicPr>
+              <p:cNvPr id="12" name="Picture 11" descr="logo_brain_transp_512x512.png">
+                <a:extLst>
+                  <a:ext uri="{FF2B5EF4-FFF2-40B4-BE49-F238E27FC236}">
+                    <a16:creationId xmlns:a16="http://schemas.microsoft.com/office/drawing/2014/main" id="{7DAA6B1B-308F-5B04-63BD-92071CA90C1A}"/>
+                  </a:ext>
+                </a:extLst>
+              </p:cNvPr>
+              <p:cNvPicPr>
+                <a:picLocks noChangeAspect="1"/>
+              </p:cNvPicPr>
+              <p:nvPr/>
+            </p:nvPicPr>
+            <p:blipFill>
+              <a:blip r:embed="rId2">
+                <a:extLst>
+                  <a:ext uri="{28A0092B-C50C-407E-A947-70E740481C1C}">
+                    <a14:useLocalDpi xmlns:a14="http://schemas.microsoft.com/office/drawing/2010/main" val="0"/>
+                  </a:ext>
+                </a:extLst>
+              </a:blip>
+              <a:stretch>
+                <a:fillRect/>
+              </a:stretch>
+            </p:blipFill>
+            <p:spPr>
+              <a:xfrm>
+                <a:off x="1776922" y="2065594"/>
+                <a:ext cx="2154717" cy="2154717"/>
+              </a:xfrm>
+              <a:prstGeom prst="rect">
+                <a:avLst/>
+              </a:prstGeom>
+            </p:spPr>
+          </p:pic>
+        </p:grpSp>
+        <p:pic>
+          <p:nvPicPr>
+            <p:cNvPr id="28" name="Graphic 27">
+              <a:extLst>
+                <a:ext uri="{FF2B5EF4-FFF2-40B4-BE49-F238E27FC236}">
+                  <a16:creationId xmlns:a16="http://schemas.microsoft.com/office/drawing/2014/main" id="{4F21AB3E-9187-B62B-071D-CEFDFEC265A5}"/>
+                </a:ext>
+              </a:extLst>
+            </p:cNvPr>
+            <p:cNvPicPr>
+              <a:picLocks noChangeAspect="1"/>
+            </p:cNvPicPr>
+            <p:nvPr/>
+          </p:nvPicPr>
+          <p:blipFill>
+            <a:blip r:embed="rId3">
+              <a:extLst>
+                <a:ext uri="{28A0092B-C50C-407E-A947-70E740481C1C}">
+                  <a14:useLocalDpi xmlns:a14="http://schemas.microsoft.com/office/drawing/2010/main" val="0"/>
+                </a:ext>
+                <a:ext uri="{96DAC541-7B7A-43D3-8B79-37D633B846F1}">
+                  <asvg:svgBlip xmlns:asvg="http://schemas.microsoft.com/office/drawing/2016/SVG/main" r:embed="rId4"/>
+                </a:ext>
+              </a:extLst>
+            </a:blip>
+            <a:stretch>
+              <a:fillRect/>
+            </a:stretch>
+          </p:blipFill>
+          <p:spPr>
+            <a:xfrm>
+              <a:off x="3403363" y="4040966"/>
+              <a:ext cx="731520" cy="731520"/>
+            </a:xfrm>
+            <a:prstGeom prst="rect">
+              <a:avLst/>
+            </a:prstGeom>
+          </p:spPr>
+        </p:pic>
+      </p:grpSp>
+      <p:grpSp>
+        <p:nvGrpSpPr>
+          <p:cNvPr id="30" name="Group 29">
+            <a:extLst>
+              <a:ext uri="{FF2B5EF4-FFF2-40B4-BE49-F238E27FC236}">
+                <a16:creationId xmlns:a16="http://schemas.microsoft.com/office/drawing/2014/main" id="{115ED77B-9C38-C544-5FF7-C751FD544198}"/>
+              </a:ext>
+            </a:extLst>
+          </p:cNvPr>
+          <p:cNvGrpSpPr/>
+          <p:nvPr/>
+        </p:nvGrpSpPr>
+        <p:grpSpPr>
+          <a:xfrm>
+            <a:off x="1845798" y="3009793"/>
+            <a:ext cx="1973342" cy="2103826"/>
+            <a:chOff x="1845798" y="3009793"/>
+            <a:chExt cx="1973342" cy="2103826"/>
+          </a:xfrm>
+        </p:grpSpPr>
+        <p:grpSp>
+          <p:nvGrpSpPr>
+            <p:cNvPr id="13" name="Group 12">
+              <a:extLst>
+                <a:ext uri="{FF2B5EF4-FFF2-40B4-BE49-F238E27FC236}">
+                  <a16:creationId xmlns:a16="http://schemas.microsoft.com/office/drawing/2014/main" id="{B2E4F815-A6AB-2E3D-7B1B-3124D316CAE4}"/>
+                </a:ext>
+              </a:extLst>
+            </p:cNvPr>
+            <p:cNvGrpSpPr>
+              <a:grpSpLocks noChangeAspect="1"/>
+            </p:cNvGrpSpPr>
+            <p:nvPr/>
+          </p:nvGrpSpPr>
+          <p:grpSpPr>
+            <a:xfrm>
+              <a:off x="1845798" y="3009793"/>
+              <a:ext cx="1834490" cy="1875247"/>
+              <a:chOff x="1544285" y="1840138"/>
+              <a:chExt cx="3619837" cy="3700267"/>
+            </a:xfrm>
+          </p:grpSpPr>
+          <p:sp>
+            <p:nvSpPr>
+              <p:cNvPr id="14" name="Folded Corner 13">
+                <a:extLst>
+                  <a:ext uri="{FF2B5EF4-FFF2-40B4-BE49-F238E27FC236}">
+                    <a16:creationId xmlns:a16="http://schemas.microsoft.com/office/drawing/2014/main" id="{35FE6374-9C6A-E938-E245-B8EE342170FF}"/>
+                  </a:ext>
+                </a:extLst>
+              </p:cNvPr>
+              <p:cNvSpPr/>
+              <p:nvPr/>
+            </p:nvSpPr>
+            <p:spPr>
+              <a:xfrm rot="10800000" flipH="1">
+                <a:off x="2674223" y="2150156"/>
+                <a:ext cx="2489899" cy="3390249"/>
+              </a:xfrm>
+              <a:prstGeom prst="foldedCorner">
+                <a:avLst>
+                  <a:gd name="adj" fmla="val 26556"/>
+                </a:avLst>
+              </a:prstGeom>
+              <a:solidFill>
+                <a:srgbClr val="052A48"/>
+              </a:solidFill>
+              <a:ln w="38100" cmpd="sng">
+                <a:solidFill>
+                  <a:schemeClr val="bg1"/>
+                </a:solidFill>
+              </a:ln>
+              <a:effectLst/>
+            </p:spPr>
+            <p:style>
+              <a:lnRef idx="1">
+                <a:schemeClr val="accent1"/>
+              </a:lnRef>
+              <a:fillRef idx="3">
+                <a:schemeClr val="accent1"/>
+              </a:fillRef>
+              <a:effectRef idx="2">
+                <a:schemeClr val="accent1"/>
+              </a:effectRef>
+              <a:fontRef idx="minor">
+                <a:schemeClr val="lt1"/>
+              </a:fontRef>
+            </p:style>
+            <p:txBody>
+              <a:bodyPr rtlCol="0" anchor="ctr"/>
+              <a:lstStyle/>
+              <a:p>
+                <a:pPr algn="ctr"/>
+                <a:r>
+                  <a:rPr lang="en-US" sz="2000" u="sng" dirty="0"/>
+                  <a:t>					   </a:t>
+                </a:r>
+              </a:p>
+            </p:txBody>
+          </p:sp>
+          <p:sp>
+            <p:nvSpPr>
+              <p:cNvPr id="15" name="Oval 14">
+                <a:extLst>
+                  <a:ext uri="{FF2B5EF4-FFF2-40B4-BE49-F238E27FC236}">
+                    <a16:creationId xmlns:a16="http://schemas.microsoft.com/office/drawing/2014/main" id="{08FC520F-63D4-A9E1-AD47-C7FA0B85404C}"/>
+                  </a:ext>
+                </a:extLst>
+              </p:cNvPr>
+              <p:cNvSpPr/>
+              <p:nvPr/>
+            </p:nvSpPr>
+            <p:spPr>
+              <a:xfrm>
+                <a:off x="1544285" y="1840138"/>
+                <a:ext cx="2478024" cy="2481818"/>
+              </a:xfrm>
+              <a:prstGeom prst="ellipse">
+                <a:avLst/>
+              </a:prstGeom>
+              <a:solidFill>
+                <a:schemeClr val="bg1"/>
+              </a:solidFill>
+              <a:ln w="76200" cmpd="sng">
+                <a:solidFill>
+                  <a:srgbClr val="052A48"/>
+                </a:solidFill>
+              </a:ln>
+              <a:effectLst/>
+            </p:spPr>
+            <p:style>
+              <a:lnRef idx="1">
+                <a:schemeClr val="accent1"/>
+              </a:lnRef>
+              <a:fillRef idx="3">
+                <a:schemeClr val="accent1"/>
+              </a:fillRef>
+              <a:effectRef idx="2">
+                <a:schemeClr val="accent1"/>
+              </a:effectRef>
+              <a:fontRef idx="minor">
+                <a:schemeClr val="lt1"/>
+              </a:fontRef>
+            </p:style>
+            <p:txBody>
+              <a:bodyPr rtlCol="0" anchor="ctr"/>
+              <a:lstStyle/>
+              <a:p>
+                <a:endParaRPr lang="en-US" sz="4400" dirty="0"/>
+              </a:p>
+            </p:txBody>
+          </p:sp>
+          <p:pic>
+            <p:nvPicPr>
+              <p:cNvPr id="16" name="Picture 15" descr="logo_brain_transp_512x512.png">
+                <a:extLst>
+                  <a:ext uri="{FF2B5EF4-FFF2-40B4-BE49-F238E27FC236}">
+                    <a16:creationId xmlns:a16="http://schemas.microsoft.com/office/drawing/2014/main" id="{D0C57689-9937-675F-4B4E-DE5B244302EA}"/>
+                  </a:ext>
+                </a:extLst>
+              </p:cNvPr>
+              <p:cNvPicPr>
+                <a:picLocks noChangeAspect="1"/>
+              </p:cNvPicPr>
+              <p:nvPr/>
+            </p:nvPicPr>
+            <p:blipFill>
+              <a:blip r:embed="rId2">
+                <a:extLst>
+                  <a:ext uri="{28A0092B-C50C-407E-A947-70E740481C1C}">
+                    <a14:useLocalDpi xmlns:a14="http://schemas.microsoft.com/office/drawing/2010/main" val="0"/>
+                  </a:ext>
+                </a:extLst>
+              </a:blip>
+              <a:stretch>
+                <a:fillRect/>
+              </a:stretch>
+            </p:blipFill>
+            <p:spPr>
+              <a:xfrm>
+                <a:off x="1776923" y="2065594"/>
+                <a:ext cx="2154717" cy="2154718"/>
+              </a:xfrm>
+              <a:prstGeom prst="rect">
+                <a:avLst/>
+              </a:prstGeom>
+            </p:spPr>
+          </p:pic>
+        </p:grpSp>
+        <p:pic>
+          <p:nvPicPr>
+            <p:cNvPr id="25" name="Graphic 24">
+              <a:extLst>
+                <a:ext uri="{FF2B5EF4-FFF2-40B4-BE49-F238E27FC236}">
+                  <a16:creationId xmlns:a16="http://schemas.microsoft.com/office/drawing/2014/main" id="{8535795A-6B29-A80E-323A-376985343170}"/>
+                </a:ext>
+              </a:extLst>
+            </p:cNvPr>
+            <p:cNvPicPr>
+              <a:picLocks noChangeAspect="1"/>
+            </p:cNvPicPr>
+            <p:nvPr/>
+          </p:nvPicPr>
+          <p:blipFill>
+            <a:blip r:embed="rId3">
+              <a:extLst>
+                <a:ext uri="{28A0092B-C50C-407E-A947-70E740481C1C}">
+                  <a14:useLocalDpi xmlns:a14="http://schemas.microsoft.com/office/drawing/2010/main" val="0"/>
+                </a:ext>
+                <a:ext uri="{96DAC541-7B7A-43D3-8B79-37D633B846F1}">
+                  <asvg:svgBlip xmlns:asvg="http://schemas.microsoft.com/office/drawing/2016/SVG/main" r:embed="rId4"/>
+                </a:ext>
+              </a:extLst>
+            </a:blip>
+            <a:stretch>
+              <a:fillRect/>
+            </a:stretch>
+          </p:blipFill>
+          <p:spPr>
+            <a:xfrm>
+              <a:off x="3087620" y="4382099"/>
+              <a:ext cx="731520" cy="731520"/>
+            </a:xfrm>
+            <a:prstGeom prst="rect">
+              <a:avLst/>
+            </a:prstGeom>
+          </p:spPr>
+        </p:pic>
+      </p:grpSp>
+      <p:sp>
+        <p:nvSpPr>
+          <p:cNvPr id="26" name="Rectangle 25">
+            <a:extLst>
+              <a:ext uri="{FF2B5EF4-FFF2-40B4-BE49-F238E27FC236}">
+                <a16:creationId xmlns:a16="http://schemas.microsoft.com/office/drawing/2014/main" id="{217F646C-9719-14B7-7C33-4C1EDEE3A37C}"/>
+              </a:ext>
+            </a:extLst>
+          </p:cNvPr>
+          <p:cNvSpPr/>
+          <p:nvPr/>
+        </p:nvSpPr>
+        <p:spPr>
+          <a:xfrm>
+            <a:off x="863980" y="855015"/>
+            <a:ext cx="7213708" cy="1754326"/>
+          </a:xfrm>
+          <a:prstGeom prst="rect">
+            <a:avLst/>
+          </a:prstGeom>
+        </p:spPr>
+        <p:txBody>
+          <a:bodyPr wrap="square">
+            <a:spAutoFit/>
+          </a:bodyPr>
+          <a:lstStyle/>
+          <a:p>
+            <a:pPr algn="ctr"/>
+            <a:r>
+              <a:rPr lang="en-US" sz="5400" b="1" dirty="0">
+                <a:solidFill>
+                  <a:srgbClr val="052B48"/>
+                </a:solidFill>
+                <a:latin typeface="Calibri"/>
+                <a:cs typeface="Calibri"/>
+              </a:rPr>
+              <a:t>Annotating Multiple NWB Files with HERD</a:t>
+            </a:r>
+          </a:p>
+        </p:txBody>
+      </p:sp>
+      <p:pic>
+        <p:nvPicPr>
+          <p:cNvPr id="21" name="Picture 20" descr="www-1632431_1280.png">
+            <a:extLst>
+              <a:ext uri="{FF2B5EF4-FFF2-40B4-BE49-F238E27FC236}">
+                <a16:creationId xmlns:a16="http://schemas.microsoft.com/office/drawing/2014/main" id="{BD7938F2-685D-6557-E8D5-8C6C4315FE80}"/>
+              </a:ext>
+            </a:extLst>
+          </p:cNvPr>
+          <p:cNvPicPr>
+            <a:picLocks noChangeAspect="1"/>
+          </p:cNvPicPr>
+          <p:nvPr/>
+        </p:nvPicPr>
+        <p:blipFill>
+          <a:blip r:embed="rId5">
+            <a:duotone>
+              <a:schemeClr val="accent5">
+                <a:shade val="45000"/>
+                <a:satMod val="135000"/>
+              </a:schemeClr>
+              <a:prstClr val="white"/>
+            </a:duotone>
+            <a:extLst>
+              <a:ext uri="{28A0092B-C50C-407E-A947-70E740481C1C}">
+                <a14:useLocalDpi xmlns:a14="http://schemas.microsoft.com/office/drawing/2010/main" val="0"/>
+              </a:ext>
+            </a:extLst>
+          </a:blip>
+          <a:stretch>
+            <a:fillRect/>
+          </a:stretch>
+        </p:blipFill>
+        <p:spPr>
+          <a:xfrm>
+            <a:off x="5452853" y="3018310"/>
+            <a:ext cx="1920497" cy="1866483"/>
+          </a:xfrm>
+          <a:prstGeom prst="rect">
+            <a:avLst/>
+          </a:prstGeom>
+        </p:spPr>
+      </p:pic>
+      <p:sp>
+        <p:nvSpPr>
+          <p:cNvPr id="22" name="Left Arrow 21">
+            <a:extLst>
+              <a:ext uri="{FF2B5EF4-FFF2-40B4-BE49-F238E27FC236}">
+                <a16:creationId xmlns:a16="http://schemas.microsoft.com/office/drawing/2014/main" id="{A3EA5341-11A6-7B92-CA95-CFF425CCD66E}"/>
+              </a:ext>
+            </a:extLst>
+          </p:cNvPr>
+          <p:cNvSpPr/>
+          <p:nvPr/>
+        </p:nvSpPr>
+        <p:spPr>
+          <a:xfrm rot="10800000" flipV="1">
+            <a:off x="4205223" y="3740567"/>
+            <a:ext cx="1122271" cy="421971"/>
+          </a:xfrm>
+          <a:prstGeom prst="leftArrow">
+            <a:avLst>
+              <a:gd name="adj1" fmla="val 46274"/>
+              <a:gd name="adj2" fmla="val 162557"/>
+            </a:avLst>
+          </a:prstGeom>
+          <a:solidFill>
+            <a:srgbClr val="D17128"/>
+          </a:solidFill>
+          <a:ln w="9525" cmpd="sng">
+            <a:noFill/>
+          </a:ln>
+        </p:spPr>
+        <p:style>
+          <a:lnRef idx="0">
+            <a:schemeClr val="accent1">
+              <a:tint val="60000"/>
+              <a:hueOff val="0"/>
+              <a:satOff val="0"/>
+              <a:lumOff val="0"/>
+              <a:alphaOff val="0"/>
+            </a:schemeClr>
+          </a:lnRef>
+          <a:fillRef idx="1">
+            <a:schemeClr val="accent1">
+              <a:tint val="60000"/>
+              <a:hueOff val="0"/>
+              <a:satOff val="0"/>
+              <a:lumOff val="0"/>
+              <a:alphaOff val="0"/>
+            </a:schemeClr>
+          </a:fillRef>
+          <a:effectRef idx="0">
+            <a:schemeClr val="accent1">
+              <a:tint val="60000"/>
+              <a:hueOff val="0"/>
+              <a:satOff val="0"/>
+              <a:lumOff val="0"/>
+              <a:alphaOff val="0"/>
+            </a:schemeClr>
+          </a:effectRef>
+          <a:fontRef idx="minor">
+            <a:schemeClr val="lt1"/>
+          </a:fontRef>
+        </p:style>
+        <p:txBody>
+          <a:bodyPr/>
+          <a:lstStyle/>
+          <a:p>
+            <a:endParaRPr lang="en-US"/>
+          </a:p>
+        </p:txBody>
+      </p:sp>
+      <p:pic>
+        <p:nvPicPr>
+          <p:cNvPr id="24" name="Graphic 23">
+            <a:extLst>
+              <a:ext uri="{FF2B5EF4-FFF2-40B4-BE49-F238E27FC236}">
+                <a16:creationId xmlns:a16="http://schemas.microsoft.com/office/drawing/2014/main" id="{8E87B66D-16A5-64DE-C5B2-0C41C3A69397}"/>
+              </a:ext>
+            </a:extLst>
+          </p:cNvPr>
+          <p:cNvPicPr>
+            <a:picLocks noChangeAspect="1"/>
+          </p:cNvPicPr>
+          <p:nvPr/>
+        </p:nvPicPr>
+        <p:blipFill>
+          <a:blip r:embed="rId6">
+            <a:extLst>
+              <a:ext uri="{28A0092B-C50C-407E-A947-70E740481C1C}">
+                <a14:useLocalDpi xmlns:a14="http://schemas.microsoft.com/office/drawing/2010/main" val="0"/>
+              </a:ext>
+              <a:ext uri="{96DAC541-7B7A-43D3-8B79-37D633B846F1}">
+                <asvg:svgBlip xmlns:asvg="http://schemas.microsoft.com/office/drawing/2016/SVG/main" r:embed="rId7"/>
+              </a:ext>
+            </a:extLst>
+          </a:blip>
+          <a:stretch>
+            <a:fillRect/>
+          </a:stretch>
+        </p:blipFill>
+        <p:spPr>
+          <a:xfrm>
+            <a:off x="4442691" y="3277250"/>
+            <a:ext cx="431505" cy="431505"/>
+          </a:xfrm>
+          <a:prstGeom prst="rect">
+            <a:avLst/>
+          </a:prstGeom>
+        </p:spPr>
+      </p:pic>
+      <p:grpSp>
+        <p:nvGrpSpPr>
+          <p:cNvPr id="31" name="Group 30">
+            <a:extLst>
+              <a:ext uri="{FF2B5EF4-FFF2-40B4-BE49-F238E27FC236}">
+                <a16:creationId xmlns:a16="http://schemas.microsoft.com/office/drawing/2014/main" id="{0B4FAD6D-8680-1D9C-0A14-EC1660E9DD12}"/>
+              </a:ext>
+            </a:extLst>
+          </p:cNvPr>
+          <p:cNvGrpSpPr/>
+          <p:nvPr/>
+        </p:nvGrpSpPr>
+        <p:grpSpPr>
+          <a:xfrm>
+            <a:off x="1514727" y="3335890"/>
+            <a:ext cx="1985884" cy="2103826"/>
+            <a:chOff x="1514727" y="3335890"/>
+            <a:chExt cx="1985884" cy="2103826"/>
+          </a:xfrm>
+        </p:grpSpPr>
+        <p:grpSp>
+          <p:nvGrpSpPr>
+            <p:cNvPr id="17" name="Group 16">
+              <a:extLst>
+                <a:ext uri="{FF2B5EF4-FFF2-40B4-BE49-F238E27FC236}">
+                  <a16:creationId xmlns:a16="http://schemas.microsoft.com/office/drawing/2014/main" id="{437FFF61-EE99-4FE7-68DC-0CA6327A7F5D}"/>
+                </a:ext>
+              </a:extLst>
+            </p:cNvPr>
+            <p:cNvGrpSpPr>
+              <a:grpSpLocks noChangeAspect="1"/>
+            </p:cNvGrpSpPr>
+            <p:nvPr/>
+          </p:nvGrpSpPr>
+          <p:grpSpPr>
+            <a:xfrm>
+              <a:off x="1514727" y="3335890"/>
+              <a:ext cx="1834490" cy="1875247"/>
+              <a:chOff x="1544285" y="1840138"/>
+              <a:chExt cx="3619836" cy="3700266"/>
+            </a:xfrm>
+          </p:grpSpPr>
+          <p:sp>
+            <p:nvSpPr>
+              <p:cNvPr id="18" name="Folded Corner 17">
+                <a:extLst>
+                  <a:ext uri="{FF2B5EF4-FFF2-40B4-BE49-F238E27FC236}">
+                    <a16:creationId xmlns:a16="http://schemas.microsoft.com/office/drawing/2014/main" id="{55ED054F-69D1-E6E1-8C17-20E0D357FCBE}"/>
+                  </a:ext>
+                </a:extLst>
+              </p:cNvPr>
+              <p:cNvSpPr/>
+              <p:nvPr/>
+            </p:nvSpPr>
+            <p:spPr>
+              <a:xfrm rot="10800000" flipH="1">
+                <a:off x="2674222" y="2150156"/>
+                <a:ext cx="2489899" cy="3390248"/>
+              </a:xfrm>
+              <a:prstGeom prst="foldedCorner">
+                <a:avLst>
+                  <a:gd name="adj" fmla="val 26556"/>
+                </a:avLst>
+              </a:prstGeom>
+              <a:solidFill>
+                <a:srgbClr val="052A48"/>
+              </a:solidFill>
+              <a:ln w="38100" cmpd="sng">
+                <a:solidFill>
+                  <a:schemeClr val="bg1"/>
+                </a:solidFill>
+              </a:ln>
+              <a:effectLst/>
+            </p:spPr>
+            <p:style>
+              <a:lnRef idx="1">
+                <a:schemeClr val="accent1"/>
+              </a:lnRef>
+              <a:fillRef idx="3">
+                <a:schemeClr val="accent1"/>
+              </a:fillRef>
+              <a:effectRef idx="2">
+                <a:schemeClr val="accent1"/>
+              </a:effectRef>
+              <a:fontRef idx="minor">
+                <a:schemeClr val="lt1"/>
+              </a:fontRef>
+            </p:style>
+            <p:txBody>
+              <a:bodyPr rtlCol="0" anchor="ctr"/>
+              <a:lstStyle/>
+              <a:p>
+                <a:pPr algn="ctr"/>
+                <a:r>
+                  <a:rPr lang="en-US" sz="2000" u="sng" dirty="0"/>
+                  <a:t>					   </a:t>
+                </a:r>
+              </a:p>
+            </p:txBody>
+          </p:sp>
+          <p:sp>
+            <p:nvSpPr>
+              <p:cNvPr id="19" name="Oval 18">
+                <a:extLst>
+                  <a:ext uri="{FF2B5EF4-FFF2-40B4-BE49-F238E27FC236}">
+                    <a16:creationId xmlns:a16="http://schemas.microsoft.com/office/drawing/2014/main" id="{17003DBB-4827-5518-5E7D-1F751E6A78A0}"/>
+                  </a:ext>
+                </a:extLst>
+              </p:cNvPr>
+              <p:cNvSpPr/>
+              <p:nvPr/>
+            </p:nvSpPr>
+            <p:spPr>
+              <a:xfrm>
+                <a:off x="1544285" y="1840138"/>
+                <a:ext cx="2478024" cy="2481818"/>
+              </a:xfrm>
+              <a:prstGeom prst="ellipse">
+                <a:avLst/>
+              </a:prstGeom>
+              <a:solidFill>
+                <a:schemeClr val="bg1"/>
+              </a:solidFill>
+              <a:ln w="76200" cmpd="sng">
+                <a:solidFill>
+                  <a:srgbClr val="052A48"/>
+                </a:solidFill>
+              </a:ln>
+              <a:effectLst/>
+            </p:spPr>
+            <p:style>
+              <a:lnRef idx="1">
+                <a:schemeClr val="accent1"/>
+              </a:lnRef>
+              <a:fillRef idx="3">
+                <a:schemeClr val="accent1"/>
+              </a:fillRef>
+              <a:effectRef idx="2">
+                <a:schemeClr val="accent1"/>
+              </a:effectRef>
+              <a:fontRef idx="minor">
+                <a:schemeClr val="lt1"/>
+              </a:fontRef>
+            </p:style>
+            <p:txBody>
+              <a:bodyPr rtlCol="0" anchor="ctr"/>
+              <a:lstStyle/>
+              <a:p>
+                <a:endParaRPr lang="en-US" sz="4400" dirty="0"/>
+              </a:p>
+            </p:txBody>
+          </p:sp>
+          <p:pic>
+            <p:nvPicPr>
+              <p:cNvPr id="20" name="Picture 19" descr="logo_brain_transp_512x512.png">
+                <a:extLst>
+                  <a:ext uri="{FF2B5EF4-FFF2-40B4-BE49-F238E27FC236}">
+                    <a16:creationId xmlns:a16="http://schemas.microsoft.com/office/drawing/2014/main" id="{9647747D-62FE-EA69-E5CD-63F40BFDC3D0}"/>
+                  </a:ext>
+                </a:extLst>
+              </p:cNvPr>
+              <p:cNvPicPr>
+                <a:picLocks noChangeAspect="1"/>
+              </p:cNvPicPr>
+              <p:nvPr/>
+            </p:nvPicPr>
+            <p:blipFill>
+              <a:blip r:embed="rId2">
+                <a:extLst>
+                  <a:ext uri="{28A0092B-C50C-407E-A947-70E740481C1C}">
+                    <a14:useLocalDpi xmlns:a14="http://schemas.microsoft.com/office/drawing/2010/main" val="0"/>
+                  </a:ext>
+                </a:extLst>
+              </a:blip>
+              <a:stretch>
+                <a:fillRect/>
+              </a:stretch>
+            </p:blipFill>
+            <p:spPr>
+              <a:xfrm>
+                <a:off x="1776922" y="2065594"/>
+                <a:ext cx="2154717" cy="2154717"/>
+              </a:xfrm>
+              <a:prstGeom prst="rect">
+                <a:avLst/>
+              </a:prstGeom>
+            </p:spPr>
+          </p:pic>
+        </p:grpSp>
+        <p:pic>
+          <p:nvPicPr>
+            <p:cNvPr id="8" name="Graphic 7">
+              <a:extLst>
+                <a:ext uri="{FF2B5EF4-FFF2-40B4-BE49-F238E27FC236}">
+                  <a16:creationId xmlns:a16="http://schemas.microsoft.com/office/drawing/2014/main" id="{B7D15FAF-23C4-0E1B-46CB-76029B0172F5}"/>
+                </a:ext>
+              </a:extLst>
+            </p:cNvPr>
+            <p:cNvPicPr>
+              <a:picLocks noChangeAspect="1"/>
+            </p:cNvPicPr>
+            <p:nvPr/>
+          </p:nvPicPr>
+          <p:blipFill>
+            <a:blip r:embed="rId3">
+              <a:extLst>
+                <a:ext uri="{28A0092B-C50C-407E-A947-70E740481C1C}">
+                  <a14:useLocalDpi xmlns:a14="http://schemas.microsoft.com/office/drawing/2010/main" val="0"/>
+                </a:ext>
+                <a:ext uri="{96DAC541-7B7A-43D3-8B79-37D633B846F1}">
+                  <asvg:svgBlip xmlns:asvg="http://schemas.microsoft.com/office/drawing/2016/SVG/main" r:embed="rId4"/>
+                </a:ext>
+              </a:extLst>
+            </a:blip>
+            <a:stretch>
+              <a:fillRect/>
+            </a:stretch>
+          </p:blipFill>
+          <p:spPr>
+            <a:xfrm>
+              <a:off x="2769091" y="4708196"/>
+              <a:ext cx="731520" cy="731520"/>
+            </a:xfrm>
+            <a:prstGeom prst="rect">
+              <a:avLst/>
+            </a:prstGeom>
+          </p:spPr>
+        </p:pic>
+      </p:grpSp>
+    </p:spTree>
+    <p:extLst>
+      <p:ext uri="{BB962C8B-B14F-4D97-AF65-F5344CB8AC3E}">
+        <p14:creationId xmlns:p14="http://schemas.microsoft.com/office/powerpoint/2010/main" val="3382530033"/>
+      </p:ext>
+    </p:extLst>
+  </p:cSld>
+  <p:clrMapOvr>
+    <a:masterClrMapping/>
+  </p:clrMapOvr>
+</p:sld>
+</file>
+
 <file path=ppt/slides/slide3.xml><?xml version="1.0" encoding="utf-8"?>
 <p:sld xmlns:a="http://schemas.openxmlformats.org/drawingml/2006/main" xmlns:r="http://schemas.openxmlformats.org/officeDocument/2006/relationships" xmlns:p="http://schemas.openxmlformats.org/presentationml/2006/main">
   <p:cSld>

</xml_diff>